<commit_message>
Deployed a18d100 with MkDocs version: 1.6.1
</commit_message>
<xml_diff>
--- a/tema1/diapositivas/primer-contacto-aws.pptx
+++ b/tema1/diapositivas/primer-contacto-aws.pptx
@@ -4406,78 +4406,37 @@
               </a:rPr>
               <a:t>Una cuenta se compromete porque su contraseña era 123456.</a:t>
             </a:r>
-            <a:endParaRPr lang="en-US" sz="2000" dirty="0"/>
-          </a:p>
-        </p:txBody>
-      </p:sp>
-      <p:sp>
-        <p:nvSpPr>
-          <p:cNvPr id="6" name="Shape 4"/>
-          <p:cNvSpPr/>
-          <p:nvPr/>
-        </p:nvSpPr>
-        <p:spPr>
-          <a:xfrm>
-            <a:off x="548640" y="4663440"/>
-            <a:ext cx="11091672" cy="822960"/>
-          </a:xfrm>
-          <a:prstGeom prst="roundRect">
-            <a:avLst/>
-          </a:prstGeom>
-          <a:solidFill>
-            <a:srgbClr val="FFF8E1"/>
-          </a:solidFill>
-          <a:ln w="19050">
-            <a:solidFill>
-              <a:srgbClr val="FFA000"/>
-            </a:solidFill>
-            <a:prstDash val="solid"/>
-          </a:ln>
-        </p:spPr>
-        <p:txBody>
-          <a:bodyPr/>
-          <a:lstStyle/>
-          <a:p>
-            <a:endParaRPr lang="es-ES"/>
-          </a:p>
-        </p:txBody>
-      </p:sp>
-      <p:sp>
-        <p:nvSpPr>
-          <p:cNvPr id="7" name="Text 5"/>
-          <p:cNvSpPr/>
-          <p:nvPr/>
-        </p:nvSpPr>
-        <p:spPr>
-          <a:xfrm>
-            <a:off x="822960" y="4754880"/>
-            <a:ext cx="10543032" cy="640080"/>
-          </a:xfrm>
-          <a:prstGeom prst="rect">
-            <a:avLst/>
-          </a:prstGeom>
-          <a:noFill/>
-          <a:ln/>
-        </p:spPr>
-        <p:txBody>
-          <a:bodyPr wrap="square" rtlCol="0" anchor="ctr"/>
-          <a:lstStyle/>
-          <a:p>
-            <a:pPr marL="0" indent="0">
-              <a:buNone/>
+          </a:p>
+          <a:p>
+            <a:pPr marL="342900" indent="-342900">
+              <a:spcAft>
+                <a:spcPts val="1200"/>
+              </a:spcAft>
+              <a:buSzPct val="100000"/>
+              <a:buChar char="•"/>
             </a:pPr>
-            <a:r>
-              <a:rPr lang="en-US" sz="2000" dirty="0">
-                <a:solidFill>
-                  <a:srgbClr val="212121"/>
-                </a:solidFill>
-                <a:latin typeface="Arial" pitchFamily="34" charset="0"/>
-                <a:ea typeface="Arial" pitchFamily="34" charset="-122"/>
-                <a:cs typeface="Arial" pitchFamily="34" charset="-120"/>
-              </a:rPr>
-              <a:t>Vas a repartir estos seis incidentes de verdad, con justificación, en la Parte B de la Actividad 1.1.</a:t>
-            </a:r>
-            <a:endParaRPr lang="en-US" sz="2000" dirty="0"/>
+            <a:endParaRPr lang="en-US" sz="2000" dirty="0">
+              <a:solidFill>
+                <a:srgbClr val="212121"/>
+              </a:solidFill>
+              <a:latin typeface="Arial" pitchFamily="34" charset="0"/>
+              <a:cs typeface="Arial" pitchFamily="34" charset="-120"/>
+            </a:endParaRPr>
+          </a:p>
+          <a:p>
+            <a:pPr>
+              <a:spcAft>
+                <a:spcPts val="1200"/>
+              </a:spcAft>
+              <a:buSzPct val="100000"/>
+            </a:pPr>
+            <a:endParaRPr lang="en-US" sz="2000" dirty="0">
+              <a:solidFill>
+                <a:srgbClr val="212121"/>
+              </a:solidFill>
+              <a:latin typeface="Arial" pitchFamily="34" charset="0"/>
+              <a:cs typeface="Arial" pitchFamily="34" charset="-120"/>
+            </a:endParaRPr>
           </a:p>
         </p:txBody>
       </p:sp>

</xml_diff>

<commit_message>
Deployed 8eb45db with MkDocs version: 1.6.1
</commit_message>
<xml_diff>
--- a/tema1/diapositivas/primer-contacto-aws.pptx
+++ b/tema1/diapositivas/primer-contacto-aws.pptx
@@ -4406,37 +4406,78 @@
               </a:rPr>
               <a:t>Una cuenta se compromete porque su contraseña era 123456.</a:t>
             </a:r>
-          </a:p>
-          <a:p>
-            <a:pPr marL="342900" indent="-342900">
-              <a:spcAft>
-                <a:spcPts val="1200"/>
-              </a:spcAft>
-              <a:buSzPct val="100000"/>
-              <a:buChar char="•"/>
+            <a:endParaRPr lang="en-US" sz="2000" dirty="0"/>
+          </a:p>
+        </p:txBody>
+      </p:sp>
+      <p:sp>
+        <p:nvSpPr>
+          <p:cNvPr id="6" name="Shape 4"/>
+          <p:cNvSpPr/>
+          <p:nvPr/>
+        </p:nvSpPr>
+        <p:spPr>
+          <a:xfrm>
+            <a:off x="548640" y="4663440"/>
+            <a:ext cx="11091672" cy="822960"/>
+          </a:xfrm>
+          <a:prstGeom prst="roundRect">
+            <a:avLst/>
+          </a:prstGeom>
+          <a:solidFill>
+            <a:srgbClr val="FFF8E1"/>
+          </a:solidFill>
+          <a:ln w="19050">
+            <a:solidFill>
+              <a:srgbClr val="FFA000"/>
+            </a:solidFill>
+            <a:prstDash val="solid"/>
+          </a:ln>
+        </p:spPr>
+        <p:txBody>
+          <a:bodyPr/>
+          <a:lstStyle/>
+          <a:p>
+            <a:endParaRPr lang="es-ES"/>
+          </a:p>
+        </p:txBody>
+      </p:sp>
+      <p:sp>
+        <p:nvSpPr>
+          <p:cNvPr id="7" name="Text 5"/>
+          <p:cNvSpPr/>
+          <p:nvPr/>
+        </p:nvSpPr>
+        <p:spPr>
+          <a:xfrm>
+            <a:off x="822960" y="4754880"/>
+            <a:ext cx="10543032" cy="640080"/>
+          </a:xfrm>
+          <a:prstGeom prst="rect">
+            <a:avLst/>
+          </a:prstGeom>
+          <a:noFill/>
+          <a:ln/>
+        </p:spPr>
+        <p:txBody>
+          <a:bodyPr wrap="square" rtlCol="0" anchor="ctr"/>
+          <a:lstStyle/>
+          <a:p>
+            <a:pPr marL="0" indent="0">
+              <a:buNone/>
             </a:pPr>
-            <a:endParaRPr lang="en-US" sz="2000" dirty="0">
-              <a:solidFill>
-                <a:srgbClr val="212121"/>
-              </a:solidFill>
-              <a:latin typeface="Arial" pitchFamily="34" charset="0"/>
-              <a:cs typeface="Arial" pitchFamily="34" charset="-120"/>
-            </a:endParaRPr>
-          </a:p>
-          <a:p>
-            <a:pPr>
-              <a:spcAft>
-                <a:spcPts val="1200"/>
-              </a:spcAft>
-              <a:buSzPct val="100000"/>
-            </a:pPr>
-            <a:endParaRPr lang="en-US" sz="2000" dirty="0">
-              <a:solidFill>
-                <a:srgbClr val="212121"/>
-              </a:solidFill>
-              <a:latin typeface="Arial" pitchFamily="34" charset="0"/>
-              <a:cs typeface="Arial" pitchFamily="34" charset="-120"/>
-            </a:endParaRPr>
+            <a:r>
+              <a:rPr lang="en-US" sz="2000" dirty="0">
+                <a:solidFill>
+                  <a:srgbClr val="212121"/>
+                </a:solidFill>
+                <a:latin typeface="Arial" pitchFamily="34" charset="0"/>
+                <a:ea typeface="Arial" pitchFamily="34" charset="-122"/>
+                <a:cs typeface="Arial" pitchFamily="34" charset="-120"/>
+              </a:rPr>
+              <a:t>Vas a repartir estos seis incidentes de verdad, con justificación, en la Parte B de la Actividad 1.1.</a:t>
+            </a:r>
+            <a:endParaRPr lang="en-US" sz="2000" dirty="0"/>
           </a:p>
         </p:txBody>
       </p:sp>

</xml_diff>